<commit_message>
updated the github links
</commit_message>
<xml_diff>
--- a/01-keycloak-basics/what-is-keycloak.pptx
+++ b/01-keycloak-basics/what-is-keycloak.pptx
@@ -5,7 +5,7 @@
     <p:sldMasterId id="2147483648" r:id="rId1"/>
   </p:sldMasterIdLst>
   <p:notesMasterIdLst>
-    <p:notesMasterId r:id="rId21"/>
+    <p:notesMasterId r:id="rId22"/>
   </p:notesMasterIdLst>
   <p:sldIdLst>
     <p:sldId id="256" r:id="rId2"/>
@@ -22,12 +22,12 @@
     <p:sldId id="274" r:id="rId13"/>
     <p:sldId id="267" r:id="rId14"/>
     <p:sldId id="268" r:id="rId15"/>
-    <p:sldId id="275" r:id="rId26"/>
-    <p:sldId id="269" r:id="rId16"/>
-    <p:sldId id="270" r:id="rId17"/>
-    <p:sldId id="271" r:id="rId18"/>
-    <p:sldId id="272" r:id="rId19"/>
-    <p:sldId id="273" r:id="rId20"/>
+    <p:sldId id="275" r:id="rId16"/>
+    <p:sldId id="269" r:id="rId17"/>
+    <p:sldId id="270" r:id="rId18"/>
+    <p:sldId id="271" r:id="rId19"/>
+    <p:sldId id="272" r:id="rId20"/>
+    <p:sldId id="273" r:id="rId21"/>
   </p:sldIdLst>
   <p:sldSz cx="10058400" cy="7772400"/>
   <p:notesSz cx="7772400" cy="10058400"/>
@@ -858,76 +858,7 @@
           <a:chExt cx="0" cy="0"/>
         </a:xfrm>
       </p:grpSpPr>
-      <p:sp>
-        <p:nvSpPr>
-          <p:cNvPr id="2" name="Slide Image Placeholder 1"/>
-          <p:cNvSpPr>
-            <a:spLocks noGrp="1" noRot="1" noChangeAspect="1"/>
-          </p:cNvSpPr>
-          <p:nvPr>
-            <p:ph type="sldImg"/>
-          </p:nvPr>
-        </p:nvSpPr>
-        <p:spPr/>
-        <p:txBody>
-          <a:bodyPr/>
-          <a:lstStyle/>
-          <a:p>
-            <a:endParaRPr lang="en-IN"/>
-          </a:p>
-        </p:txBody>
-      </p:sp>
-      <p:sp>
-        <p:nvSpPr>
-          <p:cNvPr id="3" name="Notes Placeholder 2"/>
-          <p:cNvSpPr>
-            <a:spLocks noGrp="1"/>
-          </p:cNvSpPr>
-          <p:nvPr>
-            <p:ph type="body" idx="1"/>
-          </p:nvPr>
-        </p:nvSpPr>
-        <p:spPr/>
-        <p:txBody>
-          <a:bodyPr/>
-          <a:lstStyle/>
-          <a:p>
-            <a:r>
-              <a:rPr lang="en-US" dirty="0"/>
-              <a:t>Step 7 is shown dashed because it is implemented in Post 03. RS256 is the realm default signature algorithm; confirm under Realm settings &gt; Tokens and Realm settings &gt; Keys.</a:t>
-            </a:r>
-          </a:p>
-        </p:txBody>
-      </p:sp>
-      <p:sp>
-        <p:nvSpPr>
-          <p:cNvPr id="4" name="Slide Number Placeholder 3"/>
-          <p:cNvSpPr>
-            <a:spLocks noGrp="1"/>
-          </p:cNvSpPr>
-          <p:nvPr>
-            <p:ph type="sldNum" sz="quarter" idx="10"/>
-          </p:nvPr>
-        </p:nvSpPr>
-        <p:spPr/>
-        <p:txBody>
-          <a:bodyPr/>
-          <a:lstStyle/>
-          <a:p>
-            <a:fld id="{F7021451-1387-4CA6-816F-3879F97B5CBC}" type="slidenum">
-              <a:rPr lang="en-US"/>
-              <a:t>15</a:t>
-            </a:fld>
-            <a:endParaRPr lang="en-US"/>
-          </a:p>
-        </p:txBody>
-      </p:sp>
     </p:spTree>
-    <p:extLst>
-      <p:ext uri="{BB962C8B-B14F-4D97-AF65-F5344CB8AC3E}">
-        <p14:creationId xmlns:p14="http://schemas.microsoft.com/office/powerpoint/2010/main" val="1024086991"/>
-      </p:ext>
-    </p:extLst>
   </p:cSld>
   <p:clrMapOvr>
     <a:masterClrMapping/>
@@ -988,7 +919,7 @@
           <a:p>
             <a:r>
               <a:rPr lang="en-US" dirty="0"/>
-              <a:t>Image tag 26.7 matches the current Keycloak release line as of Sept 2026 (26.7.x). Pin the exact tag you actually used when building locally. KC_BOOTSTRAP_ADMIN_* is the 26.x variable name (older KEYCLOAK_ADMIN is deprecated).</a:t>
+              <a:t>Step 7 is shown dashed because it is implemented in Post 03. RS256 is the realm default signature algorithm; confirm under Realm settings &gt; Tokens and Realm settings &gt; Keys.</a:t>
             </a:r>
           </a:p>
         </p:txBody>
@@ -1082,7 +1013,7 @@
           <a:p>
             <a:r>
               <a:rPr lang="en-US" dirty="0"/>
-              <a:t>Mistakes limited to this topic. Group Membership mapper is configured via Client scopes; covered in a later topic.</a:t>
+              <a:t>Image tag 26.7 matches the current Keycloak release line as of Sept 2026 (26.7.x). Pin the exact tag you actually used when building locally. KC_BOOTSTRAP_ADMIN_* is the 26.x variable name (older KEYCLOAK_ADMIN is deprecated).</a:t>
             </a:r>
           </a:p>
         </p:txBody>
@@ -1176,7 +1107,7 @@
           <a:p>
             <a:r>
               <a:rPr lang="en-US" dirty="0"/>
-              <a:t>Production items are named, not explained — each gets its own post later in the series.</a:t>
+              <a:t>Mistakes limited to this topic. Group Membership mapper is configured via Client scopes; covered in a later topic.</a:t>
             </a:r>
           </a:p>
         </p:txBody>
@@ -1270,7 +1201,7 @@
           <a:p>
             <a:r>
               <a:rPr lang="en-US" dirty="0"/>
-              <a:t>Replace [REPO URL] before publishing. Topic folder name 01-keycloak-basics assumed from the earlier Post 02 README plan — confirm it matches the repo.</a:t>
+              <a:t>Production items are named, not explained — each gets its own post later in the series.</a:t>
             </a:r>
           </a:p>
         </p:txBody>
@@ -1406,7 +1337,7 @@
 </file>
 
 <file path=ppt/notesSlides/notesSlide20.xml><?xml version="1.0" encoding="utf-8"?>
-<p:notes xmlns:a="http://schemas.openxmlformats.org/drawingml/2006/main" xmlns:p="http://schemas.openxmlformats.org/presentationml/2006/main" xmlns:r="http://schemas.openxmlformats.org/officeDocument/2006/relationships">
+<p:notes xmlns:a="http://schemas.openxmlformats.org/drawingml/2006/main" xmlns:r="http://schemas.openxmlformats.org/officeDocument/2006/relationships" xmlns:p="http://schemas.openxmlformats.org/presentationml/2006/main">
   <p:cSld>
     <p:spTree>
       <p:nvGrpSpPr>
@@ -1422,7 +1353,76 @@
           <a:chExt cx="0" cy="0"/>
         </a:xfrm>
       </p:grpSpPr>
+      <p:sp>
+        <p:nvSpPr>
+          <p:cNvPr id="2" name="Slide Image Placeholder 1"/>
+          <p:cNvSpPr>
+            <a:spLocks noGrp="1" noRot="1" noChangeAspect="1"/>
+          </p:cNvSpPr>
+          <p:nvPr>
+            <p:ph type="sldImg"/>
+          </p:nvPr>
+        </p:nvSpPr>
+        <p:spPr/>
+        <p:txBody>
+          <a:bodyPr/>
+          <a:lstStyle/>
+          <a:p>
+            <a:endParaRPr lang="en-IN"/>
+          </a:p>
+        </p:txBody>
+      </p:sp>
+      <p:sp>
+        <p:nvSpPr>
+          <p:cNvPr id="3" name="Notes Placeholder 2"/>
+          <p:cNvSpPr>
+            <a:spLocks noGrp="1"/>
+          </p:cNvSpPr>
+          <p:nvPr>
+            <p:ph type="body" idx="1"/>
+          </p:nvPr>
+        </p:nvSpPr>
+        <p:spPr/>
+        <p:txBody>
+          <a:bodyPr/>
+          <a:lstStyle/>
+          <a:p>
+            <a:r>
+              <a:rPr lang="en-US" dirty="0"/>
+              <a:t>Replace [REPO URL] before publishing. Topic folder name 01-keycloak-basics assumed from the earlier Post 02 README plan — confirm it matches the repo.</a:t>
+            </a:r>
+          </a:p>
+        </p:txBody>
+      </p:sp>
+      <p:sp>
+        <p:nvSpPr>
+          <p:cNvPr id="4" name="Slide Number Placeholder 3"/>
+          <p:cNvSpPr>
+            <a:spLocks noGrp="1"/>
+          </p:cNvSpPr>
+          <p:nvPr>
+            <p:ph type="sldNum" sz="quarter" idx="10"/>
+          </p:nvPr>
+        </p:nvSpPr>
+        <p:spPr/>
+        <p:txBody>
+          <a:bodyPr/>
+          <a:lstStyle/>
+          <a:p>
+            <a:fld id="{F7021451-1387-4CA6-816F-3879F97B5CBC}" type="slidenum">
+              <a:rPr lang="en-US"/>
+              <a:t>20</a:t>
+            </a:fld>
+            <a:endParaRPr lang="en-US"/>
+          </a:p>
+        </p:txBody>
+      </p:sp>
     </p:spTree>
+    <p:extLst>
+      <p:ext uri="{BB962C8B-B14F-4D97-AF65-F5344CB8AC3E}">
+        <p14:creationId xmlns:p14="http://schemas.microsoft.com/office/powerpoint/2010/main" val="1024086991"/>
+      </p:ext>
+    </p:extLst>
   </p:cSld>
   <p:clrMapOvr>
     <a:masterClrMapping/>
@@ -2477,7 +2477,7 @@
                 <a:ea typeface="Segoe UI Semibold" pitchFamily="34" charset="-122"/>
                 <a:cs typeface="Segoe UI Semibold" pitchFamily="34" charset="-120"/>
               </a:rPr>
-              <a:t>IAM + KEYCLOAK + SPRING BOOT · POST 2 OF 20</a:t>
+              <a:t>IAM + KEYCLOAK</a:t>
             </a:r>
             <a:endParaRPr lang="en-US" sz="1000" dirty="0"/>
           </a:p>
@@ -11843,7 +11843,7 @@
         <p:spPr>
           <a:xfrm>
             <a:off x="5440680" y="2057400"/>
-            <a:ext cx="4242816" cy="1691640"/>
+            <a:ext cx="4242816" cy="1828800"/>
           </a:xfrm>
           <a:prstGeom prst="roundRect">
             <a:avLst>
@@ -11878,7 +11878,7 @@
         </p:nvSpPr>
         <p:spPr>
           <a:xfrm>
-            <a:off x="5669280" y="2221992"/>
+            <a:off x="5669280" y="2170037"/>
             <a:ext cx="3785616" cy="256032"/>
           </a:xfrm>
           <a:prstGeom prst="rect">
@@ -11917,7 +11917,7 @@
         </p:nvSpPr>
         <p:spPr>
           <a:xfrm>
-            <a:off x="5669280" y="2532888"/>
+            <a:off x="5669280" y="2480933"/>
             <a:ext cx="3785616" cy="1106424"/>
           </a:xfrm>
           <a:prstGeom prst="rect">
@@ -12750,6 +12750,91 @@
               <a:t> and admin/admin are for your laptop only — see slide 19.</a:t>
             </a:r>
             <a:endParaRPr lang="en-US" sz="1200" dirty="0"/>
+          </a:p>
+        </p:txBody>
+      </p:sp>
+      <p:sp>
+        <p:nvSpPr>
+          <p:cNvPr id="57" name="Text 33">
+            <a:extLst>
+              <a:ext uri="{FF2B5EF4-FFF2-40B4-BE49-F238E27FC236}">
+                <a16:creationId xmlns:a16="http://schemas.microsoft.com/office/drawing/2014/main" id="{1CDE9437-4C31-1C17-4E92-47337410ABDF}"/>
+              </a:ext>
+            </a:extLst>
+          </p:cNvPr>
+          <p:cNvSpPr txBox="1"/>
+          <p:nvPr/>
+        </p:nvSpPr>
+        <p:spPr>
+          <a:xfrm>
+            <a:off x="5581997" y="3310128"/>
+            <a:ext cx="3785616" cy="256032"/>
+          </a:xfrm>
+          <a:prstGeom prst="rect">
+            <a:avLst/>
+          </a:prstGeom>
+          <a:noFill/>
+          <a:ln/>
+        </p:spPr>
+        <p:txBody>
+          <a:bodyPr wrap="square" lIns="0" tIns="0" rIns="0" bIns="0" rtlCol="0" anchor="ctr"/>
+          <a:lstStyle/>
+          <a:p>
+            <a:endParaRPr lang="en-US" sz="1100" dirty="0">
+              <a:solidFill>
+                <a:srgbClr val="0078D4"/>
+              </a:solidFill>
+              <a:latin typeface="Segoe UI Semibold" pitchFamily="34" charset="0"/>
+              <a:cs typeface="Segoe UI Semibold" pitchFamily="34" charset="-120"/>
+            </a:endParaRPr>
+          </a:p>
+          <a:p>
+            <a:r>
+              <a:rPr lang="en-US" sz="1100" dirty="0">
+                <a:solidFill>
+                  <a:srgbClr val="0078D4"/>
+                </a:solidFill>
+                <a:latin typeface="Segoe UI Semibold" pitchFamily="34" charset="0"/>
+                <a:cs typeface="Segoe UI Semibold" pitchFamily="34" charset="-120"/>
+              </a:rPr>
+              <a:t>NOTE: </a:t>
+            </a:r>
+            <a:r>
+              <a:rPr lang="en-IN" sz="1100" dirty="0"/>
+              <a:t>Data disappears when the container is removed. To keep the realm, users and roles across restarts, use </a:t>
+            </a:r>
+            <a:r>
+              <a:rPr lang="en-IN" sz="1100" b="1" dirty="0"/>
+              <a:t>docker-</a:t>
+            </a:r>
+            <a:r>
+              <a:rPr lang="en-IN" sz="1100" b="1" dirty="0" err="1"/>
+              <a:t>compose.yml</a:t>
+            </a:r>
+            <a:r>
+              <a:rPr lang="en-IN" sz="1100" dirty="0"/>
+              <a:t> (Keycloak + PostgreSQL) from the repo folder </a:t>
+            </a:r>
+            <a:r>
+              <a:rPr lang="en-IN" sz="1100" b="1" dirty="0"/>
+              <a:t>01-keycloak-basics</a:t>
+            </a:r>
+            <a:r>
+              <a:rPr lang="en-IN" sz="1100" dirty="0"/>
+              <a:t>.</a:t>
+            </a:r>
+            <a:r>
+              <a:rPr lang="en-US" sz="1100" dirty="0">
+                <a:solidFill>
+                  <a:srgbClr val="0078D4"/>
+                </a:solidFill>
+                <a:latin typeface="Segoe UI Semibold" pitchFamily="34" charset="0"/>
+                <a:ea typeface="Segoe UI Semibold" pitchFamily="34" charset="-122"/>
+                <a:cs typeface="Segoe UI Semibold" pitchFamily="34" charset="-120"/>
+              </a:rPr>
+              <a:t>)</a:t>
+            </a:r>
+            <a:endParaRPr lang="en-US" sz="1100" dirty="0"/>
           </a:p>
         </p:txBody>
       </p:sp>
@@ -17853,9 +17938,6 @@
           <a:bodyPr wrap="square" lIns="0" tIns="0" rIns="0" bIns="0" rtlCol="0" anchor="ctr"/>
           <a:lstStyle/>
           <a:p>
-            <a:pPr marL="0" indent="0">
-              <a:buNone/>
-            </a:pPr>
             <a:r>
               <a:rPr lang="en-US" sz="1200" b="1" dirty="0">
                 <a:solidFill>
@@ -17876,7 +17958,7 @@
                 <a:ea typeface="Segoe UI" pitchFamily="34" charset="-122"/>
                 <a:cs typeface="Segoe UI" pitchFamily="34" charset="-120"/>
               </a:rPr>
-              <a:t>[REPO URL — add before publishing]</a:t>
+              <a:t>https://github.com/ajayshinde01/keycloak</a:t>
             </a:r>
             <a:endParaRPr lang="en-US" sz="1200" dirty="0"/>
           </a:p>
@@ -17997,9 +18079,6 @@
           <a:bodyPr wrap="square" lIns="0" tIns="0" rIns="0" bIns="0" rtlCol="0" anchor="t"/>
           <a:lstStyle/>
           <a:p>
-            <a:pPr marL="0" indent="0">
-              <a:buNone/>
-            </a:pPr>
             <a:r>
               <a:rPr lang="en-US" sz="1300" b="1" dirty="0">
                 <a:solidFill>
@@ -18009,7 +18088,20 @@
                 <a:ea typeface="Segoe UI" pitchFamily="34" charset="-122"/>
                 <a:cs typeface="Segoe UI" pitchFamily="34" charset="-120"/>
               </a:rPr>
-              <a:t>Get the code: [REPO URL]/01-keycloak-basics   ·   Next: Post 03 — secure a Spring Boot API</a:t>
+              <a:t>Get the code: https://github.com/ajayshinde01/keycloak/tree/main/01-keycloak-basics   </a:t>
+            </a:r>
+          </a:p>
+          <a:p>
+            <a:r>
+              <a:rPr lang="en-US" sz="1300" b="1" dirty="0">
+                <a:solidFill>
+                  <a:srgbClr val="FFFFFF"/>
+                </a:solidFill>
+                <a:latin typeface="Segoe UI" pitchFamily="34" charset="0"/>
+                <a:ea typeface="Segoe UI" pitchFamily="34" charset="-122"/>
+                <a:cs typeface="Segoe UI" pitchFamily="34" charset="-120"/>
+              </a:rPr>
+              <a:t>Next: Post 03 — secure a Spring Boot API</a:t>
             </a:r>
             <a:endParaRPr lang="en-US" sz="1300" dirty="0"/>
           </a:p>

</xml_diff>